<commit_message>
Make the Challenge slide light so slide 1 and slide 4 no longer echo
Slides 1 and 4 both read as dark heading-over-content and looked alike. The
Challenge slide is now light (white) with tinted Problem/Solution panels, dark
body text, and a Problem->Solution arrow in the side-by-side variant -- leaving
the dark title slide as the only dark slide. Each deck now reads dark cover ->
light diagram -> light demo -> light challenge. All 26 rebuilt, validate, and
render clean across the C1/C2/C3 challenge layouts; 52 files re-staged in tmp/.
</commit_message>
<xml_diff>
--- a/ppt/AdithyaReddyMadireddy_X25120280_retail-footfall-inventory.pptx
+++ b/ppt/AdithyaReddyMadireddy_X25120280_retail-footfall-inventory.pptx
@@ -3131,7 +3131,7 @@
     <p:bg>
       <p:bgPr>
         <a:solidFill>
-          <a:srgbClr val="241A30"/>
+          <a:srgbClr val="FFFFFF"/>
         </a:solidFill>
       </p:bgPr>
     </p:bg>
@@ -3157,7 +3157,7 @@
         </p:nvSpPr>
         <p:spPr>
           <a:xfrm>
-            <a:off x="640080" y="594360"/>
+            <a:off x="640080" y="502920"/>
             <a:ext cx="10972800" cy="822960"/>
           </a:xfrm>
           <a:prstGeom prst="rect">
@@ -3176,7 +3176,7 @@
             <a:r>
               <a:rPr lang="en-US" sz="2800" b="1" dirty="0">
                 <a:solidFill>
-                  <a:srgbClr val="FFFFFF"/>
+                  <a:srgbClr val="221A2E"/>
                 </a:solidFill>
                 <a:latin typeface="Century Schoolbook" pitchFamily="34" charset="0"/>
                 <a:ea typeface="Century Schoolbook" pitchFamily="34" charset="-122"/>
@@ -3205,9 +3205,9 @@
             </a:avLst>
           </a:prstGeom>
           <a:solidFill>
-            <a:srgbClr val="30253F"/>
-          </a:solidFill>
-          <a:ln w="15875">
+            <a:srgbClr val="F2EEF8"/>
+          </a:solidFill>
+          <a:ln w="19050">
             <a:solidFill>
               <a:srgbClr val="E8B23C"/>
             </a:solidFill>
@@ -3284,7 +3284,7 @@
             <a:r>
               <a:rPr lang="en-US" sz="1300" dirty="0">
                 <a:solidFill>
-                  <a:srgbClr val="DCD0EC"/>
+                  <a:srgbClr val="221A2E"/>
                 </a:solidFill>
                 <a:latin typeface="Calibri" pitchFamily="34" charset="0"/>
                 <a:ea typeface="Calibri" pitchFamily="34" charset="-122"/>
@@ -3313,11 +3313,11 @@
             </a:avLst>
           </a:prstGeom>
           <a:solidFill>
-            <a:srgbClr val="30253F"/>
-          </a:solidFill>
-          <a:ln w="15875">
+            <a:srgbClr val="F2EEF8"/>
+          </a:solidFill>
+          <a:ln w="19050">
             <a:solidFill>
-              <a:srgbClr val="9D7BC0"/>
+              <a:srgbClr val="7A52A8"/>
             </a:solidFill>
             <a:prstDash val="solid"/>
           </a:ln>
@@ -3350,7 +3350,7 @@
             <a:r>
               <a:rPr lang="en-US" sz="1900" b="1" dirty="0">
                 <a:solidFill>
-                  <a:srgbClr val="9D7BC0"/>
+                  <a:srgbClr val="7A52A8"/>
                 </a:solidFill>
                 <a:latin typeface="Century Schoolbook" pitchFamily="34" charset="0"/>
                 <a:ea typeface="Century Schoolbook" pitchFamily="34" charset="-122"/>
@@ -3392,7 +3392,7 @@
             <a:r>
               <a:rPr lang="en-US" sz="1300" dirty="0">
                 <a:solidFill>
-                  <a:srgbClr val="DCD0EC"/>
+                  <a:srgbClr val="221A2E"/>
                 </a:solidFill>
                 <a:latin typeface="Calibri" pitchFamily="34" charset="0"/>
                 <a:ea typeface="Calibri" pitchFamily="34" charset="-122"/>

</xml_diff>

<commit_message>
Remove floating text: every demo + challenge item now sits in a card
The demo slide had features floating on white (numbered rows, big ghost numbers)
and challenge had a label-left variant with floating body text -- a known AI-tell.
Now every demo feature is inside a bordered card (three arrangements: 3 columns,
3 stacked full-width rows, or 1-wide-plus-2) and every challenge is contained
Problem/Solution cards (stacked or side-by-side with an arrow). Dropped the
floating 'switch to demo' note too. Verified across all 26 via comparison
montages of slides 2/3/4. All 26 validate; 52 files re-staged in tmp/.
</commit_message>
<xml_diff>
--- a/ppt/AdithyaReddyMadireddy_X25120280_retail-footfall-inventory.pptx
+++ b/ppt/AdithyaReddyMadireddy_X25120280_retail-footfall-inventory.pptx
@@ -2675,8 +2675,35 @@
         </p:nvSpPr>
         <p:spPr>
           <a:xfrm>
-            <a:off x="731520" y="1965960"/>
-            <a:ext cx="685800" cy="685800"/>
+            <a:off x="640080" y="1874520"/>
+            <a:ext cx="3502152" cy="3977640"/>
+          </a:xfrm>
+          <a:prstGeom prst="roundRect">
+            <a:avLst>
+              <a:gd name="adj" fmla="val 2611"/>
+            </a:avLst>
+          </a:prstGeom>
+          <a:solidFill>
+            <a:srgbClr val="F2EEF8"/>
+          </a:solidFill>
+          <a:ln w="15240">
+            <a:solidFill>
+              <a:srgbClr val="7A52A8"/>
+            </a:solidFill>
+            <a:prstDash val="solid"/>
+          </a:ln>
+        </p:spPr>
+      </p:sp>
+      <p:sp>
+        <p:nvSpPr>
+          <p:cNvPr id="5" name="Shape 3"/>
+          <p:cNvSpPr/>
+          <p:nvPr/>
+        </p:nvSpPr>
+        <p:spPr>
+          <a:xfrm>
+            <a:off x="914400" y="2148840"/>
+            <a:ext cx="603504" cy="603504"/>
           </a:xfrm>
           <a:prstGeom prst="ellipse">
             <a:avLst/>
@@ -2689,14 +2716,14 @@
       </p:sp>
       <p:sp>
         <p:nvSpPr>
-          <p:cNvPr id="5" name="Text 3"/>
-          <p:cNvSpPr/>
-          <p:nvPr/>
-        </p:nvSpPr>
-        <p:spPr>
-          <a:xfrm>
-            <a:off x="731520" y="1965960"/>
-            <a:ext cx="685800" cy="685800"/>
+          <p:cNvPr id="6" name="Text 4"/>
+          <p:cNvSpPr/>
+          <p:nvPr/>
+        </p:nvSpPr>
+        <p:spPr>
+          <a:xfrm>
+            <a:off x="914400" y="2148840"/>
+            <a:ext cx="603504" cy="603504"/>
           </a:xfrm>
           <a:prstGeom prst="rect">
             <a:avLst/>
@@ -2712,7 +2739,7 @@
               <a:buNone/>
             </a:pPr>
             <a:r>
-              <a:rPr lang="en-US" sz="2600" b="1" dirty="0">
+              <a:rPr lang="en-US" sz="2200" b="1" dirty="0">
                 <a:solidFill>
                   <a:srgbClr val="FFFFFF"/>
                 </a:solidFill>
@@ -2722,20 +2749,20 @@
               </a:rPr>
               <a:t>1</a:t>
             </a:r>
-            <a:endParaRPr lang="en-US" sz="2600" dirty="0"/>
-          </a:p>
-        </p:txBody>
-      </p:sp>
-      <p:sp>
-        <p:nvSpPr>
-          <p:cNvPr id="6" name="Text 4"/>
-          <p:cNvSpPr/>
-          <p:nvPr/>
-        </p:nvSpPr>
-        <p:spPr>
-          <a:xfrm>
-            <a:off x="1691640" y="1920240"/>
-            <a:ext cx="9875520" cy="411480"/>
+            <a:endParaRPr lang="en-US" sz="2200" dirty="0"/>
+          </a:p>
+        </p:txBody>
+      </p:sp>
+      <p:sp>
+        <p:nvSpPr>
+          <p:cNvPr id="7" name="Text 5"/>
+          <p:cNvSpPr/>
+          <p:nvPr/>
+        </p:nvSpPr>
+        <p:spPr>
+          <a:xfrm>
+            <a:off x="914400" y="2898648"/>
+            <a:ext cx="2953512" cy="777240"/>
           </a:xfrm>
           <a:prstGeom prst="rect">
             <a:avLst/>
@@ -2751,7 +2778,7 @@
               <a:buNone/>
             </a:pPr>
             <a:r>
-              <a:rPr lang="en-US" sz="1800" b="1" dirty="0">
+              <a:rPr lang="en-US" sz="1600" b="1" dirty="0">
                 <a:solidFill>
                   <a:srgbClr val="221A2E"/>
                 </a:solidFill>
@@ -2761,20 +2788,20 @@
               </a:rPr>
               <a:t>Four estate KPIs, then per store</a:t>
             </a:r>
-            <a:endParaRPr lang="en-US" sz="1800" dirty="0"/>
-          </a:p>
-        </p:txBody>
-      </p:sp>
-      <p:sp>
-        <p:nvSpPr>
-          <p:cNvPr id="7" name="Text 5"/>
-          <p:cNvSpPr/>
-          <p:nvPr/>
-        </p:nvSpPr>
-        <p:spPr>
-          <a:xfrm>
-            <a:off x="1691640" y="2340864"/>
-            <a:ext cx="9875520" cy="640080"/>
+            <a:endParaRPr lang="en-US" sz="1600" dirty="0"/>
+          </a:p>
+        </p:txBody>
+      </p:sp>
+      <p:sp>
+        <p:nvSpPr>
+          <p:cNvPr id="8" name="Text 6"/>
+          <p:cNvSpPr/>
+          <p:nvPr/>
+        </p:nvSpPr>
+        <p:spPr>
+          <a:xfrm>
+            <a:off x="914400" y="3657600"/>
+            <a:ext cx="2953512" cy="2011680"/>
           </a:xfrm>
           <a:prstGeom prst="rect">
             <a:avLst/>
@@ -2787,10 +2814,13 @@
           <a:lstStyle/>
           <a:p>
             <a:pPr indent="0" marL="0">
-              <a:buNone/>
-            </a:pPr>
-            <a:r>
-              <a:rPr lang="en-US" sz="1350" dirty="0">
+              <a:lnSpc>
+                <a:spcPct val="106000"/>
+              </a:lnSpc>
+              <a:buNone/>
+            </a:pPr>
+            <a:r>
+              <a:rPr lang="en-US" sz="1250" dirty="0">
                 <a:solidFill>
                   <a:srgbClr val="6A5F78"/>
                 </a:solidFill>
@@ -2800,20 +2830,47 @@
               </a:rPr>
               <a:t>Footfall, shelf stock, fridge temperature, queue length and energy draw roll up to four estate tiles, then break out per store.</a:t>
             </a:r>
-            <a:endParaRPr lang="en-US" sz="1350" dirty="0"/>
-          </a:p>
-        </p:txBody>
-      </p:sp>
-      <p:sp>
-        <p:nvSpPr>
-          <p:cNvPr id="8" name="Shape 6"/>
-          <p:cNvSpPr/>
-          <p:nvPr/>
-        </p:nvSpPr>
-        <p:spPr>
-          <a:xfrm>
-            <a:off x="731520" y="3383280"/>
-            <a:ext cx="685800" cy="685800"/>
+            <a:endParaRPr lang="en-US" sz="1250" dirty="0"/>
+          </a:p>
+        </p:txBody>
+      </p:sp>
+      <p:sp>
+        <p:nvSpPr>
+          <p:cNvPr id="9" name="Shape 7"/>
+          <p:cNvSpPr/>
+          <p:nvPr/>
+        </p:nvSpPr>
+        <p:spPr>
+          <a:xfrm>
+            <a:off x="4416552" y="1874520"/>
+            <a:ext cx="3502152" cy="3977640"/>
+          </a:xfrm>
+          <a:prstGeom prst="roundRect">
+            <a:avLst>
+              <a:gd name="adj" fmla="val 2611"/>
+            </a:avLst>
+          </a:prstGeom>
+          <a:solidFill>
+            <a:srgbClr val="F2EEF8"/>
+          </a:solidFill>
+          <a:ln w="15240">
+            <a:solidFill>
+              <a:srgbClr val="7A52A8"/>
+            </a:solidFill>
+            <a:prstDash val="solid"/>
+          </a:ln>
+        </p:spPr>
+      </p:sp>
+      <p:sp>
+        <p:nvSpPr>
+          <p:cNvPr id="10" name="Shape 8"/>
+          <p:cNvSpPr/>
+          <p:nvPr/>
+        </p:nvSpPr>
+        <p:spPr>
+          <a:xfrm>
+            <a:off x="4690872" y="2148840"/>
+            <a:ext cx="603504" cy="603504"/>
           </a:xfrm>
           <a:prstGeom prst="ellipse">
             <a:avLst/>
@@ -2826,14 +2883,14 @@
       </p:sp>
       <p:sp>
         <p:nvSpPr>
-          <p:cNvPr id="9" name="Text 7"/>
-          <p:cNvSpPr/>
-          <p:nvPr/>
-        </p:nvSpPr>
-        <p:spPr>
-          <a:xfrm>
-            <a:off x="731520" y="3383280"/>
-            <a:ext cx="685800" cy="685800"/>
+          <p:cNvPr id="11" name="Text 9"/>
+          <p:cNvSpPr/>
+          <p:nvPr/>
+        </p:nvSpPr>
+        <p:spPr>
+          <a:xfrm>
+            <a:off x="4690872" y="2148840"/>
+            <a:ext cx="603504" cy="603504"/>
           </a:xfrm>
           <a:prstGeom prst="rect">
             <a:avLst/>
@@ -2849,7 +2906,7 @@
               <a:buNone/>
             </a:pPr>
             <a:r>
-              <a:rPr lang="en-US" sz="2600" b="1" dirty="0">
+              <a:rPr lang="en-US" sz="2200" b="1" dirty="0">
                 <a:solidFill>
                   <a:srgbClr val="FFFFFF"/>
                 </a:solidFill>
@@ -2859,20 +2916,20 @@
               </a:rPr>
               <a:t>2</a:t>
             </a:r>
-            <a:endParaRPr lang="en-US" sz="2600" dirty="0"/>
-          </a:p>
-        </p:txBody>
-      </p:sp>
-      <p:sp>
-        <p:nvSpPr>
-          <p:cNvPr id="10" name="Text 8"/>
-          <p:cNvSpPr/>
-          <p:nvPr/>
-        </p:nvSpPr>
-        <p:spPr>
-          <a:xfrm>
-            <a:off x="1691640" y="3337560"/>
-            <a:ext cx="9875520" cy="411480"/>
+            <a:endParaRPr lang="en-US" sz="2200" dirty="0"/>
+          </a:p>
+        </p:txBody>
+      </p:sp>
+      <p:sp>
+        <p:nvSpPr>
+          <p:cNvPr id="12" name="Text 10"/>
+          <p:cNvSpPr/>
+          <p:nvPr/>
+        </p:nvSpPr>
+        <p:spPr>
+          <a:xfrm>
+            <a:off x="4690872" y="2898648"/>
+            <a:ext cx="2953512" cy="777240"/>
           </a:xfrm>
           <a:prstGeom prst="rect">
             <a:avLst/>
@@ -2888,7 +2945,7 @@
               <a:buNone/>
             </a:pPr>
             <a:r>
-              <a:rPr lang="en-US" sz="1800" b="1" dirty="0">
+              <a:rPr lang="en-US" sz="1600" b="1" dirty="0">
                 <a:solidFill>
                   <a:srgbClr val="221A2E"/>
                 </a:solidFill>
@@ -2898,20 +2955,20 @@
               </a:rPr>
               <a:t>Mixed-polarity rules</a:t>
             </a:r>
-            <a:endParaRPr lang="en-US" sz="1800" dirty="0"/>
-          </a:p>
-        </p:txBody>
-      </p:sp>
-      <p:sp>
-        <p:nvSpPr>
-          <p:cNvPr id="11" name="Text 9"/>
-          <p:cNvSpPr/>
-          <p:nvPr/>
-        </p:nvSpPr>
-        <p:spPr>
-          <a:xfrm>
-            <a:off x="1691640" y="3758184"/>
-            <a:ext cx="9875520" cy="640080"/>
+            <a:endParaRPr lang="en-US" sz="1600" dirty="0"/>
+          </a:p>
+        </p:txBody>
+      </p:sp>
+      <p:sp>
+        <p:nvSpPr>
+          <p:cNvPr id="13" name="Text 11"/>
+          <p:cNvSpPr/>
+          <p:nvPr/>
+        </p:nvSpPr>
+        <p:spPr>
+          <a:xfrm>
+            <a:off x="4690872" y="3657600"/>
+            <a:ext cx="2953512" cy="2011680"/>
           </a:xfrm>
           <a:prstGeom prst="rect">
             <a:avLst/>
@@ -2924,10 +2981,13 @@
           <a:lstStyle/>
           <a:p>
             <a:pPr indent="0" marL="0">
-              <a:buNone/>
-            </a:pPr>
-            <a:r>
-              <a:rPr lang="en-US" sz="1350" dirty="0">
+              <a:lnSpc>
+                <a:spcPct val="106000"/>
+              </a:lnSpc>
+              <a:buNone/>
+            </a:pPr>
+            <a:r>
+              <a:rPr lang="en-US" sz="1250" dirty="0">
                 <a:solidFill>
                   <a:srgbClr val="6A5F78"/>
                 </a:solidFill>
@@ -2937,20 +2997,47 @@
               </a:rPr>
               <a:t>Shelf stock has a depletion floor while queue and footfall have ceilings — each raises the moment its window crosses in the right direction.</a:t>
             </a:r>
-            <a:endParaRPr lang="en-US" sz="1350" dirty="0"/>
-          </a:p>
-        </p:txBody>
-      </p:sp>
-      <p:sp>
-        <p:nvSpPr>
-          <p:cNvPr id="12" name="Shape 10"/>
-          <p:cNvSpPr/>
-          <p:nvPr/>
-        </p:nvSpPr>
-        <p:spPr>
-          <a:xfrm>
-            <a:off x="731520" y="4800600"/>
-            <a:ext cx="685800" cy="685800"/>
+            <a:endParaRPr lang="en-US" sz="1250" dirty="0"/>
+          </a:p>
+        </p:txBody>
+      </p:sp>
+      <p:sp>
+        <p:nvSpPr>
+          <p:cNvPr id="14" name="Shape 12"/>
+          <p:cNvSpPr/>
+          <p:nvPr/>
+        </p:nvSpPr>
+        <p:spPr>
+          <a:xfrm>
+            <a:off x="8193024" y="1874520"/>
+            <a:ext cx="3502152" cy="3977640"/>
+          </a:xfrm>
+          <a:prstGeom prst="roundRect">
+            <a:avLst>
+              <a:gd name="adj" fmla="val 2611"/>
+            </a:avLst>
+          </a:prstGeom>
+          <a:solidFill>
+            <a:srgbClr val="F2EEF8"/>
+          </a:solidFill>
+          <a:ln w="15240">
+            <a:solidFill>
+              <a:srgbClr val="7A52A8"/>
+            </a:solidFill>
+            <a:prstDash val="solid"/>
+          </a:ln>
+        </p:spPr>
+      </p:sp>
+      <p:sp>
+        <p:nvSpPr>
+          <p:cNvPr id="15" name="Shape 13"/>
+          <p:cNvSpPr/>
+          <p:nvPr/>
+        </p:nvSpPr>
+        <p:spPr>
+          <a:xfrm>
+            <a:off x="8467344" y="2148840"/>
+            <a:ext cx="603504" cy="603504"/>
           </a:xfrm>
           <a:prstGeom prst="ellipse">
             <a:avLst/>
@@ -2963,14 +3050,14 @@
       </p:sp>
       <p:sp>
         <p:nvSpPr>
-          <p:cNvPr id="13" name="Text 11"/>
-          <p:cNvSpPr/>
-          <p:nvPr/>
-        </p:nvSpPr>
-        <p:spPr>
-          <a:xfrm>
-            <a:off x="731520" y="4800600"/>
-            <a:ext cx="685800" cy="685800"/>
+          <p:cNvPr id="16" name="Text 14"/>
+          <p:cNvSpPr/>
+          <p:nvPr/>
+        </p:nvSpPr>
+        <p:spPr>
+          <a:xfrm>
+            <a:off x="8467344" y="2148840"/>
+            <a:ext cx="603504" cy="603504"/>
           </a:xfrm>
           <a:prstGeom prst="rect">
             <a:avLst/>
@@ -2986,7 +3073,7 @@
               <a:buNone/>
             </a:pPr>
             <a:r>
-              <a:rPr lang="en-US" sz="2600" b="1" dirty="0">
+              <a:rPr lang="en-US" sz="2200" b="1" dirty="0">
                 <a:solidFill>
                   <a:srgbClr val="FFFFFF"/>
                 </a:solidFill>
@@ -2996,20 +3083,20 @@
               </a:rPr>
               <a:t>3</a:t>
             </a:r>
-            <a:endParaRPr lang="en-US" sz="2600" dirty="0"/>
-          </a:p>
-        </p:txBody>
-      </p:sp>
-      <p:sp>
-        <p:nvSpPr>
-          <p:cNvPr id="14" name="Text 12"/>
-          <p:cNvSpPr/>
-          <p:nvPr/>
-        </p:nvSpPr>
-        <p:spPr>
-          <a:xfrm>
-            <a:off x="1691640" y="4754880"/>
-            <a:ext cx="9875520" cy="411480"/>
+            <a:endParaRPr lang="en-US" sz="2200" dirty="0"/>
+          </a:p>
+        </p:txBody>
+      </p:sp>
+      <p:sp>
+        <p:nvSpPr>
+          <p:cNvPr id="17" name="Text 15"/>
+          <p:cNvSpPr/>
+          <p:nvPr/>
+        </p:nvSpPr>
+        <p:spPr>
+          <a:xfrm>
+            <a:off x="8467344" y="2898648"/>
+            <a:ext cx="2953512" cy="777240"/>
           </a:xfrm>
           <a:prstGeom prst="rect">
             <a:avLst/>
@@ -3025,7 +3112,7 @@
               <a:buNone/>
             </a:pPr>
             <a:r>
-              <a:rPr lang="en-US" sz="1800" b="1" dirty="0">
+              <a:rPr lang="en-US" sz="1600" b="1" dirty="0">
                 <a:solidFill>
                   <a:srgbClr val="221A2E"/>
                 </a:solidFill>
@@ -3035,20 +3122,20 @@
               </a:rPr>
               <a:t>A refrigeration warning on real data</a:t>
             </a:r>
-            <a:endParaRPr lang="en-US" sz="1800" dirty="0"/>
-          </a:p>
-        </p:txBody>
-      </p:sp>
-      <p:sp>
-        <p:nvSpPr>
-          <p:cNvPr id="15" name="Text 13"/>
-          <p:cNvSpPr/>
-          <p:nvPr/>
-        </p:nvSpPr>
-        <p:spPr>
-          <a:xfrm>
-            <a:off x="1691640" y="5175504"/>
-            <a:ext cx="9875520" cy="640080"/>
+            <a:endParaRPr lang="en-US" sz="1600" dirty="0"/>
+          </a:p>
+        </p:txBody>
+      </p:sp>
+      <p:sp>
+        <p:nvSpPr>
+          <p:cNvPr id="18" name="Text 16"/>
+          <p:cNvSpPr/>
+          <p:nvPr/>
+        </p:nvSpPr>
+        <p:spPr>
+          <a:xfrm>
+            <a:off x="8467344" y="3657600"/>
+            <a:ext cx="2953512" cy="2011680"/>
           </a:xfrm>
           <a:prstGeom prst="rect">
             <a:avLst/>
@@ -3061,10 +3148,13 @@
           <a:lstStyle/>
           <a:p>
             <a:pPr indent="0" marL="0">
-              <a:buNone/>
-            </a:pPr>
-            <a:r>
-              <a:rPr lang="en-US" sz="1350" dirty="0">
+              <a:lnSpc>
+                <a:spcPct val="106000"/>
+              </a:lnSpc>
+              <a:buNone/>
+            </a:pPr>
+            <a:r>
+              <a:rPr lang="en-US" sz="1250" dirty="0">
                 <a:solidFill>
                   <a:srgbClr val="6A5F78"/>
                 </a:solidFill>
@@ -3074,46 +3164,7 @@
               </a:rPr>
               <a:t>A fridge drifting warm in one store raises the refrigeration warning on its card while the rest stay nominal.</a:t>
             </a:r>
-            <a:endParaRPr lang="en-US" sz="1350" dirty="0"/>
-          </a:p>
-        </p:txBody>
-      </p:sp>
-      <p:sp>
-        <p:nvSpPr>
-          <p:cNvPr id="16" name="Text 14"/>
-          <p:cNvSpPr/>
-          <p:nvPr/>
-        </p:nvSpPr>
-        <p:spPr>
-          <a:xfrm>
-            <a:off x="640080" y="6263640"/>
-            <a:ext cx="10972800" cy="365760"/>
-          </a:xfrm>
-          <a:prstGeom prst="rect">
-            <a:avLst/>
-          </a:prstGeom>
-          <a:noFill/>
-          <a:ln/>
-        </p:spPr>
-        <p:txBody>
-          <a:bodyPr wrap="square" rtlCol="0" anchor="ctr"/>
-          <a:lstStyle/>
-          <a:p>
-            <a:pPr indent="0" marL="0">
-              <a:buNone/>
-            </a:pPr>
-            <a:r>
-              <a:rPr lang="en-US" sz="1300" i="1" dirty="0">
-                <a:solidFill>
-                  <a:srgbClr val="9D7BC0"/>
-                </a:solidFill>
-                <a:latin typeface="Calibri" pitchFamily="34" charset="0"/>
-                <a:ea typeface="Calibri" pitchFamily="34" charset="-122"/>
-                <a:cs typeface="Calibri" pitchFamily="34" charset="-120"/>
-              </a:rPr>
-              <a:t>Switch to the live dashboard here — backup video ready.</a:t>
-            </a:r>
-            <a:endParaRPr lang="en-US" sz="1300" dirty="0"/>
+            <a:endParaRPr lang="en-US" sz="1250" dirty="0"/>
           </a:p>
         </p:txBody>
       </p:sp>

</xml_diff>

<commit_message>
Vary the cover text/theme so title slides stop looking alike
The covers shared a dark theme, identical amber pill chips, and an identical
footer line -- so they read as one template. Now: removed the repeated footer
(the brief's slide-1 spec is only project name + name + one-line problem); mixed
light and dark cover themes (8 light / 18 dark); and gave the motivation cues
four interchangeable styles (outlined pills / solid chips / inline tag line /
stat-square markers) with per-deck accent colours. Accent TEXT is forced bright
on dark and dark-green on light for guaranteed contrast. All 26 validate and
render clean; 52 files re-staged in tmp/.
</commit_message>
<xml_diff>
--- a/ppt/AdithyaReddyMadireddy_X25120280_retail-footfall-inventory.pptx
+++ b/ppt/AdithyaReddyMadireddy_X25120280_retail-footfall-inventory.pptx
@@ -1484,17 +1484,6 @@
             <a:pPr indent="0" marL="0">
               <a:buNone/>
             </a:pPr>
-            <a:r>
-              <a:rPr lang="en-US" sz="1300" dirty="0">
-                <a:solidFill>
-                  <a:srgbClr val="6A5F78"/>
-                </a:solidFill>
-                <a:latin typeface="Calibri" pitchFamily="34" charset="0"/>
-                <a:ea typeface="Calibri" pitchFamily="34" charset="-122"/>
-                <a:cs typeface="Calibri" pitchFamily="34" charset="-120"/>
-              </a:rPr>
-              <a:t>Fog &amp; Edge Computing (H9FECC)   ·   deployed live on AWS</a:t>
-            </a:r>
             <a:endParaRPr lang="en-US" sz="1300" dirty="0"/>
           </a:p>
         </p:txBody>

</xml_diff>